<commit_message>
Update workshop presentation with new content
</commit_message>
<xml_diff>
--- a/From Architecture to Terraform Workshop.pptx
+++ b/From Architecture to Terraform Workshop.pptx
@@ -15135,7 +15135,7 @@
         </p:blipFill>
         <p:spPr>
           <a:xfrm>
-            <a:off x="7021657" y="1919402"/>
+            <a:off x="7021657" y="788431"/>
             <a:ext cx="4286250" cy="4286250"/>
           </a:xfrm>
           <a:prstGeom prst="rect">
@@ -15143,6 +15143,74 @@
           </a:prstGeom>
         </p:spPr>
       </p:pic>
+      <p:sp>
+        <p:nvSpPr>
+          <p:cNvPr id="24" name="TextBox 23">
+            <a:extLst>
+              <a:ext uri="{FF2B5EF4-FFF2-40B4-BE49-F238E27FC236}">
+                <a16:creationId xmlns:a16="http://schemas.microsoft.com/office/drawing/2014/main" id="{46460D67-0306-BDA9-64DB-74298F7D97E1}"/>
+              </a:ext>
+            </a:extLst>
+          </p:cNvPr>
+          <p:cNvSpPr txBox="1"/>
+          <p:nvPr/>
+        </p:nvSpPr>
+        <p:spPr>
+          <a:xfrm>
+            <a:off x="6565733" y="5303283"/>
+            <a:ext cx="5626267" cy="830997"/>
+          </a:xfrm>
+          <a:prstGeom prst="rect">
+            <a:avLst/>
+          </a:prstGeom>
+          <a:noFill/>
+        </p:spPr>
+        <p:txBody>
+          <a:bodyPr wrap="square">
+            <a:spAutoFit/>
+          </a:bodyPr>
+          <a:lstStyle/>
+          <a:p>
+            <a:r>
+              <a:rPr lang="en-US" sz="2400" dirty="0">
+                <a:solidFill>
+                  <a:schemeClr val="bg1"/>
+                </a:solidFill>
+              </a:rPr>
+              <a:t>github.com/</a:t>
+            </a:r>
+            <a:r>
+              <a:rPr lang="en-US" sz="2400" dirty="0" err="1">
+                <a:solidFill>
+                  <a:schemeClr val="bg1"/>
+                </a:solidFill>
+              </a:rPr>
+              <a:t>TaleLearnCode</a:t>
+            </a:r>
+            <a:r>
+              <a:rPr lang="en-US" sz="2400" dirty="0">
+                <a:solidFill>
+                  <a:schemeClr val="bg1"/>
+                </a:solidFill>
+              </a:rPr>
+              <a:t>/ </a:t>
+            </a:r>
+            <a:r>
+              <a:rPr lang="en-US" sz="2400" dirty="0" err="1">
+                <a:solidFill>
+                  <a:schemeClr val="bg1"/>
+                </a:solidFill>
+              </a:rPr>
+              <a:t>FromArchitectureToTerraformWorkshop</a:t>
+            </a:r>
+            <a:endParaRPr lang="en-US" sz="2400" dirty="0">
+              <a:solidFill>
+                <a:schemeClr val="bg1"/>
+              </a:solidFill>
+            </a:endParaRPr>
+          </a:p>
+        </p:txBody>
+      </p:sp>
     </p:spTree>
   </p:cSld>
   <p:clrMapOvr>

</xml_diff>